<commit_message>
docs: embed live evidence in leadership deck
Co-authored-by: Copilot App <223556219+Copilot@users.noreply.github.com>

Copilot-Session: 1679ad4f-be96-4262-bdf7-66860f3d6703
</commit_message>
<xml_diff>
--- a/docs/demo/hybrid-sandbox-leadership/hybrid-sandbox-leadership-demo.pptx
+++ b/docs/demo/hybrid-sandbox-leadership/hybrid-sandbox-leadership-demo.pptx
@@ -310,7 +310,7 @@
           <a:lstStyle/>
           <a:p>
             <a:r>
-              <a:t>This is the core of the live demo. We start a real Hosted Skill invocation, then show the same request across Function monitoring, APIM model and MCP telemetry, the ACA Sandbox Group, and Application Insights. The final edit will replace these four frames with actual captured portal evidence from the same correlated request window. No mocks and no body logging.</a:t>
+              <a:t>Every panel on this slide comes from the same live request window. The Function request returned HTTP 200 and the streaming terminal event. APIM recorded two successful model calls and four successful MCP POST calls. The ACA group moved from zero to one Running object and back to zero through the configured ownership-scoped reaper after one delete-initiation failure. Application Insights retained the content-free lifecycle waterfall. The panels are deterministic renders of the exact live query results, not fabricated values or mocked telemetry.</a:t>
             </a:r>
           </a:p>
         </p:txBody>
@@ -6647,7 +6647,7 @@
                 </a:solidFill>
                 <a:latin typeface="Segoe UI"/>
               </a:rPr>
-              <a:t>ACTUAL PORTAL VIEWS  |  SAME CORRELATED DEMO INVOCATION</a:t>
+              <a:t>LIVE QUERY EVIDENCE  |  SAME CORRELATED DEMO INVOCATION</a:t>
             </a:r>
           </a:p>
         </p:txBody>
@@ -7089,6 +7089,102 @@
           </a:p>
         </p:txBody>
       </p:sp>
+      <p:pic>
+        <p:nvPicPr>
+          <p:cNvPr id="19" name="Picture 19"/>
+          <p:cNvPicPr>
+            <a:picLocks noChangeAspect="1"/>
+          </p:cNvPicPr>
+          <p:nvPr/>
+        </p:nvPicPr>
+        <p:blipFill>
+          <a:blip r:embed="rId3"/>
+          <a:stretch>
+            <a:fillRect/>
+          </a:stretch>
+        </p:blipFill>
+        <p:spPr>
+          <a:xfrm>
+            <a:off x="650000" y="1500000"/>
+            <a:ext cx="3600000" cy="2025000"/>
+          </a:xfrm>
+          <a:prstGeom prst="rect">
+            <a:avLst/>
+          </a:prstGeom>
+        </p:spPr>
+      </p:pic>
+      <p:pic>
+        <p:nvPicPr>
+          <p:cNvPr id="20" name="Picture 20"/>
+          <p:cNvPicPr>
+            <a:picLocks noChangeAspect="1"/>
+          </p:cNvPicPr>
+          <p:nvPr/>
+        </p:nvPicPr>
+        <p:blipFill>
+          <a:blip r:embed="rId4"/>
+          <a:stretch>
+            <a:fillRect/>
+          </a:stretch>
+        </p:blipFill>
+        <p:spPr>
+          <a:xfrm>
+            <a:off x="4890000" y="1500000"/>
+            <a:ext cx="3600000" cy="2025000"/>
+          </a:xfrm>
+          <a:prstGeom prst="rect">
+            <a:avLst/>
+          </a:prstGeom>
+        </p:spPr>
+      </p:pic>
+      <p:pic>
+        <p:nvPicPr>
+          <p:cNvPr id="21" name="Picture 21"/>
+          <p:cNvPicPr>
+            <a:picLocks noChangeAspect="1"/>
+          </p:cNvPicPr>
+          <p:nvPr/>
+        </p:nvPicPr>
+        <p:blipFill>
+          <a:blip r:embed="rId5"/>
+          <a:stretch>
+            <a:fillRect/>
+          </a:stretch>
+        </p:blipFill>
+        <p:spPr>
+          <a:xfrm>
+            <a:off x="650000" y="3950000"/>
+            <a:ext cx="3600000" cy="2025000"/>
+          </a:xfrm>
+          <a:prstGeom prst="rect">
+            <a:avLst/>
+          </a:prstGeom>
+        </p:spPr>
+      </p:pic>
+      <p:pic>
+        <p:nvPicPr>
+          <p:cNvPr id="22" name="Picture 22"/>
+          <p:cNvPicPr>
+            <a:picLocks noChangeAspect="1"/>
+          </p:cNvPicPr>
+          <p:nvPr/>
+        </p:nvPicPr>
+        <p:blipFill>
+          <a:blip r:embed="rId6"/>
+          <a:stretch>
+            <a:fillRect/>
+          </a:stretch>
+        </p:blipFill>
+        <p:spPr>
+          <a:xfrm>
+            <a:off x="4890000" y="3950000"/>
+            <a:ext cx="3600000" cy="2025000"/>
+          </a:xfrm>
+          <a:prstGeom prst="rect">
+            <a:avLst/>
+          </a:prstGeom>
+        </p:spPr>
+      </p:pic>
     </p:spTree>
   </p:cSld>
   <p:clrMapOvr>

</xml_diff>

<commit_message>
docs: embed redacted portal views in demo deck
Co-authored-by: Copilot App <223556219+Copilot@users.noreply.github.com>

Copilot-Session: 1679ad4f-be96-4262-bdf7-66860f3d6703
</commit_message>
<xml_diff>
--- a/docs/demo/hybrid-sandbox-leadership/hybrid-sandbox-leadership-demo.pptx
+++ b/docs/demo/hybrid-sandbox-leadership/hybrid-sandbox-leadership-demo.pptx
@@ -310,7 +310,7 @@
           <a:lstStyle/>
           <a:p>
             <a:r>
-              <a:t>Every panel on this slide comes from the same live request window. The Function request returned HTTP 200 and the streaming terminal event. APIM recorded two successful model calls and four successful MCP POST calls. The ACA group moved from zero to one Running object and back to zero through the configured ownership-scoped reaper after one delete-initiation failure. Application Insights retained the content-free lifecycle waterfall. The panels are deterministic renders of the exact live query results, not fabricated values or mocked telemetry.</a:t>
+              <a:t>These are redacted live Azure Portal product views from the retained spike environment. The Function App view proves the Hosted Skill endpoints are deployed and enabled. The Application Insights transaction is the same portal-evidence request and shows HTTP 200 plus correlated OTel traces. The APIM policy views prove that separate model and MCP APIs remain governed, but the exact portal-evidence request window produced no APIM diagnostic row, so this slide does not mislabel unrelated traffic as same-run evidence. The Sandbox Group view shows final zero inventory; the active one-sandbox observation comes from the separately identified qualification run. Subscription, tenant, account, build, InvocationId, ProcessId, and HostInstanceId values are excluded or visibly redacted.</a:t>
             </a:r>
           </a:p>
         </p:txBody>
@@ -6647,7 +6647,7 @@
                 </a:solidFill>
                 <a:latin typeface="Segoe UI"/>
               </a:rPr>
-              <a:t>LIVE QUERY EVIDENCE  |  SAME CORRELATED DEMO INVOCATION</a:t>
+              <a:t>REDACTED LIVE PORTAL VIEWS  |  RETAINED SPIKE RESOURCES</a:t>
             </a:r>
           </a:p>
         </p:txBody>
@@ -7084,7 +7084,7 @@
                 </a:solidFill>
                 <a:latin typeface="Segoe UI"/>
               </a:rPr>
-              <a:t>No mocks: the video uses the retained Function App, APIM APIs, Sandbox Group, and Application Insights workspace.</a:t>
+              <a:t>Live product views: Functions, APIM policy, ACA Sandbox Group, and Application Insights.</a:t>
             </a:r>
           </a:p>
         </p:txBody>
@@ -7171,6 +7171,102 @@
         </p:nvPicPr>
         <p:blipFill>
           <a:blip r:embed="rId6"/>
+          <a:stretch>
+            <a:fillRect/>
+          </a:stretch>
+        </p:blipFill>
+        <p:spPr>
+          <a:xfrm>
+            <a:off x="4890000" y="3950000"/>
+            <a:ext cx="3600000" cy="2025000"/>
+          </a:xfrm>
+          <a:prstGeom prst="rect">
+            <a:avLst/>
+          </a:prstGeom>
+        </p:spPr>
+      </p:pic>
+      <p:pic>
+        <p:nvPicPr>
+          <p:cNvPr id="23" name="Picture 23"/>
+          <p:cNvPicPr>
+            <a:picLocks noChangeAspect="1"/>
+          </p:cNvPicPr>
+          <p:nvPr/>
+        </p:nvPicPr>
+        <p:blipFill>
+          <a:blip r:embed="rId7"/>
+          <a:stretch>
+            <a:fillRect/>
+          </a:stretch>
+        </p:blipFill>
+        <p:spPr>
+          <a:xfrm>
+            <a:off x="650000" y="1500000"/>
+            <a:ext cx="3600000" cy="2025000"/>
+          </a:xfrm>
+          <a:prstGeom prst="rect">
+            <a:avLst/>
+          </a:prstGeom>
+        </p:spPr>
+      </p:pic>
+      <p:pic>
+        <p:nvPicPr>
+          <p:cNvPr id="24" name="Picture 24"/>
+          <p:cNvPicPr>
+            <a:picLocks noChangeAspect="1"/>
+          </p:cNvPicPr>
+          <p:nvPr/>
+        </p:nvPicPr>
+        <p:blipFill>
+          <a:blip r:embed="rId8"/>
+          <a:stretch>
+            <a:fillRect/>
+          </a:stretch>
+        </p:blipFill>
+        <p:spPr>
+          <a:xfrm>
+            <a:off x="4890000" y="1500000"/>
+            <a:ext cx="3600000" cy="2025000"/>
+          </a:xfrm>
+          <a:prstGeom prst="rect">
+            <a:avLst/>
+          </a:prstGeom>
+        </p:spPr>
+      </p:pic>
+      <p:pic>
+        <p:nvPicPr>
+          <p:cNvPr id="25" name="Picture 25"/>
+          <p:cNvPicPr>
+            <a:picLocks noChangeAspect="1"/>
+          </p:cNvPicPr>
+          <p:nvPr/>
+        </p:nvPicPr>
+        <p:blipFill>
+          <a:blip r:embed="rId9"/>
+          <a:stretch>
+            <a:fillRect/>
+          </a:stretch>
+        </p:blipFill>
+        <p:spPr>
+          <a:xfrm>
+            <a:off x="650000" y="3950000"/>
+            <a:ext cx="3600000" cy="2025000"/>
+          </a:xfrm>
+          <a:prstGeom prst="rect">
+            <a:avLst/>
+          </a:prstGeom>
+        </p:spPr>
+      </p:pic>
+      <p:pic>
+        <p:nvPicPr>
+          <p:cNvPr id="26" name="Picture 26"/>
+          <p:cNvPicPr>
+            <a:picLocks noChangeAspect="1"/>
+          </p:cNvPicPr>
+          <p:nvPr/>
+        </p:nvPicPr>
+        <p:blipFill>
+          <a:blip r:embed="rId10"/>
           <a:stretch>
             <a:fillRect/>
           </a:stretch>

</xml_diff>

<commit_message>
docs: update deck for live-first E2E demo
Co-authored-by: Copilot App <223556219+Copilot@users.noreply.github.com>

Copilot-Session: 1679ad4f-be96-4262-bdf7-66860f3d6703
</commit_message>
<xml_diff>
--- a/docs/demo/hybrid-sandbox-leadership/hybrid-sandbox-leadership-demo.pptx
+++ b/docs/demo/hybrid-sandbox-leadership/hybrid-sandbox-leadership-demo.pptx
@@ -310,7 +310,7 @@
           <a:lstStyle/>
           <a:p>
             <a:r>
-              <a:t>These are redacted live Azure Portal product views from the retained spike environment. The Function App view proves the Hosted Skill endpoints are deployed and enabled. The Application Insights transaction is the same portal-evidence request and shows HTTP 200 plus correlated OTel traces. The APIM policy views prove that separate model and MCP APIs remain governed, but the exact portal-evidence request window produced no APIM diagnostic row, so this slide does not mislabel unrelated traffic as same-run evidence. The Sandbox Group view shows final zero inventory; the active one-sandbox observation comes from the separately identified qualification run. Subscription, tenant, account, build, InvocationId, ProcessId, and HostInstanceId values are excluded or visibly redacted.</a:t>
+              <a:t>This is the strongest demonstration: one actual Hosted Skills request used Microsoft Learn MCP and two local shell tools, returning the MCP takeaway plus ALPHA_COMPLETE and BETA_COMPLETE. The same bounded window contains two successful model POSTs and five successful MCP POSTs through APIM. The local calls shared one invocation sandbox and were safely queued by the same-sandbox journal; this is parallel model fan-out, not simultaneous local command execution. Correlated telemetry shows 68 runtime dependency spans, create and delete timing, and final typed sandbox inventory zero without operator cleanup. The chat capture is an actual Playwright recording. The APIM and sandbox panels contain live product views. The trace panel is a content-free visualization generated from the same real Application Insights spans because the active Edge session could not be taken over safely.</a:t>
             </a:r>
           </a:p>
         </p:txBody>
@@ -6614,7 +6614,7 @@
                 </a:solidFill>
                 <a:latin typeface="Segoe UI Semibold"/>
               </a:rPr>
-              <a:t>The live proof is visible across Azure</a:t>
+              <a:t>Watch one real request cross every boundary</a:t>
             </a:r>
           </a:p>
         </p:txBody>
@@ -6647,7 +6647,7 @@
                 </a:solidFill>
                 <a:latin typeface="Segoe UI"/>
               </a:rPr>
-              <a:t>REDACTED LIVE PORTAL VIEWS  |  RETAINED SPIKE RESOURCES</a:t>
+              <a:t>LIVE-FIRST E2E EVIDENCE  |  ONE BOUNDED INVOCATION</a:t>
             </a:r>
           </a:p>
         </p:txBody>
@@ -7084,7 +7084,7 @@
                 </a:solidFill>
                 <a:latin typeface="Segoe UI"/>
               </a:rPr>
-              <a:t>Live product views: Functions, APIM policy, ACA Sandbox Group, and Application Insights.</a:t>
+              <a:t>One live Hosted Skill request: MCP + two ACA tool calls + APIM + final inventory zero.</a:t>
             </a:r>
           </a:p>
         </p:txBody>
@@ -7267,6 +7267,102 @@
         </p:nvPicPr>
         <p:blipFill>
           <a:blip r:embed="rId10"/>
+          <a:stretch>
+            <a:fillRect/>
+          </a:stretch>
+        </p:blipFill>
+        <p:spPr>
+          <a:xfrm>
+            <a:off x="4890000" y="3950000"/>
+            <a:ext cx="3600000" cy="2025000"/>
+          </a:xfrm>
+          <a:prstGeom prst="rect">
+            <a:avLst/>
+          </a:prstGeom>
+        </p:spPr>
+      </p:pic>
+      <p:pic>
+        <p:nvPicPr>
+          <p:cNvPr id="27" name="Picture 27"/>
+          <p:cNvPicPr>
+            <a:picLocks noChangeAspect="1"/>
+          </p:cNvPicPr>
+          <p:nvPr/>
+        </p:nvPicPr>
+        <p:blipFill>
+          <a:blip r:embed="rId11"/>
+          <a:stretch>
+            <a:fillRect/>
+          </a:stretch>
+        </p:blipFill>
+        <p:spPr>
+          <a:xfrm>
+            <a:off x="650000" y="1500000"/>
+            <a:ext cx="3600000" cy="2025000"/>
+          </a:xfrm>
+          <a:prstGeom prst="rect">
+            <a:avLst/>
+          </a:prstGeom>
+        </p:spPr>
+      </p:pic>
+      <p:pic>
+        <p:nvPicPr>
+          <p:cNvPr id="28" name="Picture 28"/>
+          <p:cNvPicPr>
+            <a:picLocks noChangeAspect="1"/>
+          </p:cNvPicPr>
+          <p:nvPr/>
+        </p:nvPicPr>
+        <p:blipFill>
+          <a:blip r:embed="rId12"/>
+          <a:stretch>
+            <a:fillRect/>
+          </a:stretch>
+        </p:blipFill>
+        <p:spPr>
+          <a:xfrm>
+            <a:off x="4890000" y="1500000"/>
+            <a:ext cx="3600000" cy="2025000"/>
+          </a:xfrm>
+          <a:prstGeom prst="rect">
+            <a:avLst/>
+          </a:prstGeom>
+        </p:spPr>
+      </p:pic>
+      <p:pic>
+        <p:nvPicPr>
+          <p:cNvPr id="29" name="Picture 29"/>
+          <p:cNvPicPr>
+            <a:picLocks noChangeAspect="1"/>
+          </p:cNvPicPr>
+          <p:nvPr/>
+        </p:nvPicPr>
+        <p:blipFill>
+          <a:blip r:embed="rId13"/>
+          <a:stretch>
+            <a:fillRect/>
+          </a:stretch>
+        </p:blipFill>
+        <p:spPr>
+          <a:xfrm>
+            <a:off x="650000" y="3950000"/>
+            <a:ext cx="3600000" cy="2025000"/>
+          </a:xfrm>
+          <a:prstGeom prst="rect">
+            <a:avLst/>
+          </a:prstGeom>
+        </p:spPr>
+      </p:pic>
+      <p:pic>
+        <p:nvPicPr>
+          <p:cNvPr id="30" name="Picture 30"/>
+          <p:cNvPicPr>
+            <a:picLocks noChangeAspect="1"/>
+          </p:cNvPicPr>
+          <p:nvPr/>
+        </p:nvPicPr>
+        <p:blipFill>
+          <a:blip r:embed="rId14"/>
           <a:stretch>
             <a:fillRect/>
           </a:stretch>

</xml_diff>

<commit_message>
docs: refresh live-first leadership deck
Co-authored-by: Copilot App <223556219+Copilot@users.noreply.github.com>

Copilot-Session: 5c8c2c7f-32ac-4e77-994c-c50a075d5f32
</commit_message>
<xml_diff>
--- a/docs/demo/hybrid-sandbox-leadership/hybrid-sandbox-leadership-demo.pptx
+++ b/docs/demo/hybrid-sandbox-leadership/hybrid-sandbox-leadership-demo.pptx
@@ -310,7 +310,7 @@
           <a:lstStyle/>
           <a:p>
             <a:r>
-              <a:t>These are redacted live Azure Portal product views from the retained spike environment. The Function App view proves the Hosted Skill endpoints are deployed and enabled. The Application Insights transaction is the same portal-evidence request and shows HTTP 200 plus correlated OTel traces. The APIM policy views prove that separate model and MCP APIs remain governed, but the exact portal-evidence request window produced no APIM diagnostic row, so this slide does not mislabel unrelated traffic as same-run evidence. The Sandbox Group view shows final zero inventory; the active one-sandbox observation comes from the separately identified qualification run. Subscription, tenant, account, build, InvocationId, ProcessId, and HostInstanceId values are excluded or visibly redacted.</a:t>
+              <a:t>This is the strongest demonstration: one actual Hosted Skills request used Microsoft Learn MCP and two local shell tools, returning the MCP takeaway plus ALPHA_COMPLETE and BETA_COMPLETE. The same bounded window contains two successful model POSTs and five successful MCP POSTs through APIM. The local calls shared one invocation sandbox and were safely queued by the same-sandbox journal; this is parallel model fan-out, not simultaneous local command execution. Correlated telemetry shows 68 runtime dependency spans, create and delete timing, and final typed sandbox inventory zero without operator cleanup. The chat capture is an actual Playwright recording. The APIM and sandbox panels contain live product views. The trace panel is a content-free visualization generated from the same real Application Insights spans because the active Edge session could not be taken over safely.</a:t>
             </a:r>
           </a:p>
         </p:txBody>
@@ -6614,7 +6614,7 @@
                 </a:solidFill>
                 <a:latin typeface="Segoe UI Semibold"/>
               </a:rPr>
-              <a:t>The live proof is visible across Azure</a:t>
+              <a:t>Watch one real request cross every boundary</a:t>
             </a:r>
           </a:p>
         </p:txBody>
@@ -6647,7 +6647,7 @@
                 </a:solidFill>
                 <a:latin typeface="Segoe UI"/>
               </a:rPr>
-              <a:t>REDACTED LIVE PORTAL VIEWS  |  RETAINED SPIKE RESOURCES</a:t>
+              <a:t>LIVE-FIRST E2E EVIDENCE  |  ONE BOUNDED INVOCATION</a:t>
             </a:r>
           </a:p>
         </p:txBody>
@@ -7084,7 +7084,7 @@
                 </a:solidFill>
                 <a:latin typeface="Segoe UI"/>
               </a:rPr>
-              <a:t>Live product views: Functions, APIM policy, ACA Sandbox Group, and Application Insights.</a:t>
+              <a:t>One live Hosted Skill request: MCP + two ACA tool calls + APIM + final inventory zero.</a:t>
             </a:r>
           </a:p>
         </p:txBody>
@@ -7267,6 +7267,102 @@
         </p:nvPicPr>
         <p:blipFill>
           <a:blip r:embed="rId10"/>
+          <a:stretch>
+            <a:fillRect/>
+          </a:stretch>
+        </p:blipFill>
+        <p:spPr>
+          <a:xfrm>
+            <a:off x="4890000" y="3950000"/>
+            <a:ext cx="3600000" cy="2025000"/>
+          </a:xfrm>
+          <a:prstGeom prst="rect">
+            <a:avLst/>
+          </a:prstGeom>
+        </p:spPr>
+      </p:pic>
+      <p:pic>
+        <p:nvPicPr>
+          <p:cNvPr id="27" name="Picture 27"/>
+          <p:cNvPicPr>
+            <a:picLocks noChangeAspect="1"/>
+          </p:cNvPicPr>
+          <p:nvPr/>
+        </p:nvPicPr>
+        <p:blipFill>
+          <a:blip r:embed="rId11"/>
+          <a:stretch>
+            <a:fillRect/>
+          </a:stretch>
+        </p:blipFill>
+        <p:spPr>
+          <a:xfrm>
+            <a:off x="650000" y="1500000"/>
+            <a:ext cx="3600000" cy="2025000"/>
+          </a:xfrm>
+          <a:prstGeom prst="rect">
+            <a:avLst/>
+          </a:prstGeom>
+        </p:spPr>
+      </p:pic>
+      <p:pic>
+        <p:nvPicPr>
+          <p:cNvPr id="28" name="Picture 28"/>
+          <p:cNvPicPr>
+            <a:picLocks noChangeAspect="1"/>
+          </p:cNvPicPr>
+          <p:nvPr/>
+        </p:nvPicPr>
+        <p:blipFill>
+          <a:blip r:embed="rId12"/>
+          <a:stretch>
+            <a:fillRect/>
+          </a:stretch>
+        </p:blipFill>
+        <p:spPr>
+          <a:xfrm>
+            <a:off x="4890000" y="1500000"/>
+            <a:ext cx="3600000" cy="2025000"/>
+          </a:xfrm>
+          <a:prstGeom prst="rect">
+            <a:avLst/>
+          </a:prstGeom>
+        </p:spPr>
+      </p:pic>
+      <p:pic>
+        <p:nvPicPr>
+          <p:cNvPr id="29" name="Picture 29"/>
+          <p:cNvPicPr>
+            <a:picLocks noChangeAspect="1"/>
+          </p:cNvPicPr>
+          <p:nvPr/>
+        </p:nvPicPr>
+        <p:blipFill>
+          <a:blip r:embed="rId13"/>
+          <a:stretch>
+            <a:fillRect/>
+          </a:stretch>
+        </p:blipFill>
+        <p:spPr>
+          <a:xfrm>
+            <a:off x="650000" y="3950000"/>
+            <a:ext cx="3600000" cy="2025000"/>
+          </a:xfrm>
+          <a:prstGeom prst="rect">
+            <a:avLst/>
+          </a:prstGeom>
+        </p:spPr>
+      </p:pic>
+      <p:pic>
+        <p:nvPicPr>
+          <p:cNvPr id="30" name="Picture 30"/>
+          <p:cNvPicPr>
+            <a:picLocks noChangeAspect="1"/>
+          </p:cNvPicPr>
+          <p:nvPr/>
+        </p:nvPicPr>
+        <p:blipFill>
+          <a:blip r:embed="rId14"/>
           <a:stretch>
             <a:fillRect/>
           </a:stretch>

</xml_diff>

<commit_message>
docs: publish fallback qualification results
Co-authored-by: Copilot App <223556219+Copilot@users.noreply.github.com>

Copilot-Session: 5c8c2c7f-32ac-4e77-994c-c50a075d5f32
</commit_message>
<xml_diff>
--- a/docs/demo/hybrid-sandbox-leadership/hybrid-sandbox-leadership-demo.pptx
+++ b/docs/demo/hybrid-sandbox-leadership/hybrid-sandbox-leadership-demo.pptx
@@ -271,7 +271,7 @@
           <a:lstStyle/>
           <a:p>
             <a:r>
-              <a:t>This is the measured lifecycle for each invocation. A fresh sandbox takes about three seconds to create. The optimized thin bundle uploads in about 135 milliseconds, and executor readiness averages 333 milliseconds. Local tool execution itself is sub-millisecond for the deterministic probe. Cleanup is handed off in about 50 milliseconds: we wait only for server-side delete acceptance, while autosuspend, autodelete, and the scoped reaper remain backstops. The whole request averages 10.65 seconds; model calls are now the largest variable component.</a:t>
+              <a:t>This is the measured lifecycle for each invocation in the exact-source September 5 qualification. A fresh sandbox averaged 3.15 seconds to create. The optimized thin bundle uploaded in 103 milliseconds, executor readiness averaged 464 milliseconds, and deterministic local tool execution averaged 0.28 milliseconds. Terminal lifecycle handoff averaged 77.4 milliseconds. Four invocation-handle delete requests were accepted normally; 17 timed out at the existing five-second bound and all 17 were then confirmed deleted by the separately bounded exact-ID provider fallback. The fallback itself averaged 593 milliseconds. Completed output remained intact, inventory returned to zero at every stage, and the whole runtime averaged 13.22 seconds.</a:t>
             </a:r>
           </a:p>
         </p:txBody>
@@ -349,7 +349,7 @@
           <a:lstStyle/>
           <a:p>
             <a:r>
-              <a:t>Close with measured impact and a concrete ask. Against the canonical baseline, average runtime latency dropped 48 percent, c1 p50 dropped 54 percent, and c10 p50 dropped 33 percent. All 21 optimized requests succeeded, there were no hybrid failures, inventory returned to zero, and APIM added only about 1.3 milliseconds p50 gateway overhead. The recommendation is not to call this production-ready; it is to fund a productization design for a supported customer-controlled tool execution plane.</a:t>
+              <a:t>Close with the exact-source September 5 result and a concrete ask. Against the canonical baseline, average runtime latency dropped 35.50 percent, cold latency dropped 20.52 percent, c1 p50 dropped 34.78 percent, and c10 p50 dropped 18.39 percent. All 21 nonstream requests succeeded, there were no hybrid failures, and inventory was zero before and after every stage. Four handle delete initiations were accepted normally. Seventeen stalled at the five-second bound; all 17 exact-ID provider fallbacks confirmed deletion in 593 milliseconds average without replacing completed output. The run is 2.57 seconds slower on average than the September 3 optimized result because the exceptional path paid the handle bound. APIM gateway diagnostic rows were unavailable for this clean window, so this slide does not repeat the historical gateway-overhead estimate. The recommendation is not to call this production-ready; it is to fund a productization design for a supported customer-controlled tool execution plane.</a:t>
             </a:r>
           </a:p>
         </p:txBody>
@@ -5388,7 +5388,7 @@
                 </a:solidFill>
                 <a:latin typeface="Segoe UI"/>
               </a:rPr>
-              <a:t>MEASURED CRITICAL PATH  |  OPTIMIZED LIVE QUALIFICATION</a:t>
+              <a:t>MEASURED CRITICAL PATH  |  FALLBACK-QUALIFIED LIVE RUN</a:t>
             </a:r>
           </a:p>
         </p:txBody>
@@ -5566,7 +5566,7 @@
                 </a:solidFill>
                 <a:latin typeface="Segoe UI Semibold"/>
               </a:rPr>
-              <a:t>3.01s avg</a:t>
+              <a:t>3.15s avg</a:t>
             </a:r>
           </a:p>
         </p:txBody>
@@ -5744,7 +5744,7 @@
                 </a:solidFill>
                 <a:latin typeface="Segoe UI Semibold"/>
               </a:rPr>
-              <a:t>135ms avg</a:t>
+              <a:t>103ms avg</a:t>
             </a:r>
           </a:p>
         </p:txBody>
@@ -5922,7 +5922,7 @@
                 </a:solidFill>
                 <a:latin typeface="Segoe UI Semibold"/>
               </a:rPr>
-              <a:t>333ms avg</a:t>
+              <a:t>464ms avg</a:t>
             </a:r>
           </a:p>
         </p:txBody>
@@ -6100,7 +6100,7 @@
                 </a:solidFill>
                 <a:latin typeface="Segoe UI Semibold"/>
               </a:rPr>
-              <a:t>0.30ms tool avg</a:t>
+              <a:t>0.28ms tool avg</a:t>
             </a:r>
           </a:p>
         </p:txBody>
@@ -6245,7 +6245,7 @@
                 </a:solidFill>
                 <a:latin typeface="Segoe UI"/>
               </a:rPr>
-              <a:t>Delete accepted</a:t>
+              <a:t>Exact-ID fallback</a:t>
             </a:r>
           </a:p>
         </p:txBody>
@@ -6278,7 +6278,7 @@
                 </a:solidFill>
                 <a:latin typeface="Segoe UI Semibold"/>
               </a:rPr>
-              <a:t>49.9ms avg</a:t>
+              <a:t>77.4ms avg</a:t>
             </a:r>
           </a:p>
         </p:txBody>
@@ -6482,7 +6482,7 @@
                 </a:solidFill>
                 <a:latin typeface="Segoe UI"/>
               </a:rPr>
-              <a:t>Immediate server-side delete; 300/600 policy and reaper as backstops.</a:t>
+              <a:t>Handle delete first; exact-ID provider fallback; 300/600 policy and reaper remain backstops.</a:t>
             </a:r>
           </a:p>
         </p:txBody>
@@ -6515,7 +6515,7 @@
                 </a:solidFill>
                 <a:latin typeface="Segoe UI"/>
               </a:rPr>
-              <a:t>End-to-end request average: 10.65s. Model calls remain the largest variable component.</a:t>
+              <a:t>End-to-end runtime average: 13.22s. Exact-ID provider deletion recovered 17 of 21 handle stalls.</a:t>
             </a:r>
           </a:p>
         </p:txBody>
@@ -7471,7 +7471,7 @@
                 </a:solidFill>
                 <a:latin typeface="Segoe UI Semibold"/>
               </a:rPr>
-              <a:t>The optimization cut runtime latency in half</a:t>
+              <a:t>Fallback-qualified runtime remains 35.5% below baseline</a:t>
             </a:r>
           </a:p>
         </p:txBody>
@@ -7504,7 +7504,7 @@
                 </a:solidFill>
                 <a:latin typeface="Segoe UI"/>
               </a:rPr>
-              <a:t>CANONICAL BASELINE VS. OPTIMIZED LIVE QUALIFICATION</a:t>
+              <a:t>CANONICAL BASELINE VS. EXACT-SOURCE FD6589E QUALIFICATION</a:t>
             </a:r>
           </a:p>
         </p:txBody>
@@ -7561,7 +7561,7 @@
                 </a:solidFill>
                 <a:latin typeface="Segoe UI Semibold"/>
               </a:rPr>
-              <a:t>48%</a:t>
+              <a:t>35.5%</a:t>
             </a:r>
           </a:p>
         </p:txBody>
@@ -7627,7 +7627,7 @@
                 </a:solidFill>
                 <a:latin typeface="Segoe UI"/>
               </a:rPr>
-              <a:t>20.49s  -&gt;  10.65s</a:t>
+              <a:t>20.49s  -&gt;  13.22s</a:t>
             </a:r>
           </a:p>
           <a:p>
@@ -7638,7 +7638,7 @@
                 </a:solidFill>
                 <a:latin typeface="Segoe UI"/>
               </a:rPr>
-              <a:t>Saved 9.84s per request</a:t>
+              <a:t>Saved 7.27s per request</a:t>
             </a:r>
           </a:p>
         </p:txBody>
@@ -7742,7 +7742,7 @@
         <p:spPr>
           <a:xfrm>
             <a:off x="5410000" y="2240000"/>
-            <a:ext cx="1440000" cy="240000"/>
+            <a:ext cx="1788351" cy="240000"/>
           </a:xfrm>
           <a:prstGeom prst="roundRect">
             <a:avLst/>
@@ -7796,7 +7796,7 @@
                 </a:solidFill>
                 <a:latin typeface="Segoe UI Semibold"/>
               </a:rPr>
-              <a:t>17.7s</a:t>
+              <a:t>22.0s</a:t>
             </a:r>
           </a:p>
         </p:txBody>
@@ -7867,7 +7867,7 @@
         <p:spPr>
           <a:xfrm>
             <a:off x="5410000" y="3080000"/>
-            <a:ext cx="1040000" cy="240000"/>
+            <a:ext cx="1467505" cy="240000"/>
           </a:xfrm>
           <a:prstGeom prst="roundRect">
             <a:avLst/>
@@ -7921,7 +7921,7 @@
                 </a:solidFill>
                 <a:latin typeface="Segoe UI Semibold"/>
               </a:rPr>
-              <a:t>9.1s</a:t>
+              <a:t>12.9s</a:t>
             </a:r>
           </a:p>
         </p:txBody>
@@ -7992,7 +7992,7 @@
         <p:spPr>
           <a:xfrm>
             <a:off x="5410000" y="3920000"/>
-            <a:ext cx="1510000" cy="240000"/>
+            <a:ext cx="1836169" cy="240000"/>
           </a:xfrm>
           <a:prstGeom prst="roundRect">
             <a:avLst/>
@@ -8046,7 +8046,7 @@
                 </a:solidFill>
                 <a:latin typeface="Segoe UI Semibold"/>
               </a:rPr>
-              <a:t>18.5s</a:t>
+              <a:t>22.5s</a:t>
             </a:r>
           </a:p>
         </p:txBody>
@@ -8307,7 +8307,7 @@
                 </a:solidFill>
                 <a:latin typeface="Segoe UI Semibold"/>
               </a:rPr>
-              <a:t>~1.3ms</a:t>
+              <a:t>17 / 17</a:t>
             </a:r>
           </a:p>
           <a:p>
@@ -8318,7 +8318,7 @@
                 </a:solidFill>
                 <a:latin typeface="Segoe UI"/>
               </a:rPr>
-              <a:t>APIM p50 overhead</a:t>
+              <a:t>fallback deletes confirmed</a:t>
             </a:r>
           </a:p>
         </p:txBody>

</xml_diff>